<commit_message>
Apply LIGHTYEAR brand system across web, docs, and decks
</commit_message>
<xml_diff>
--- a/brand/Lightyear-Deck-Template.pptx
+++ b/brand/Lightyear-Deck-Template.pptx
@@ -2,18 +2,18 @@
 <file path=ppt/presentation.xml><?xml version="1.0" encoding="utf-8"?>
 <p:presentation xmlns:p="http://schemas.openxmlformats.org/presentationml/2006/main">
   <p:sldMasterIdLst>
-    <p:sldMasterId xmlns:r="http://schemas.openxmlformats.org/officeDocument/2006/relationships" id="2147483648" r:id="R0900d8e81ba349bd"/>
+    <p:sldMasterId xmlns:r="http://schemas.openxmlformats.org/officeDocument/2006/relationships" id="2147483648" r:id="R213c7ba445694474"/>
   </p:sldMasterIdLst>
   <p:notesMasterIdLst>
-    <p:notesMasterId xmlns:r="http://schemas.openxmlformats.org/officeDocument/2006/relationships" r:id="R0aae193fe71645ad"/>
+    <p:notesMasterId xmlns:r="http://schemas.openxmlformats.org/officeDocument/2006/relationships" r:id="Rbbd2108c210e4aab"/>
   </p:notesMasterIdLst>
   <p:sldIdLst>
-    <p:sldId xmlns:r="http://schemas.openxmlformats.org/officeDocument/2006/relationships" id="256" r:id="R19e437bcf2144151"/>
-    <p:sldId xmlns:r="http://schemas.openxmlformats.org/officeDocument/2006/relationships" id="257" r:id="Rb9f0c9692d14494d"/>
-    <p:sldId xmlns:r="http://schemas.openxmlformats.org/officeDocument/2006/relationships" id="258" r:id="Re8c31f1d2cb04cc2"/>
-    <p:sldId xmlns:r="http://schemas.openxmlformats.org/officeDocument/2006/relationships" id="259" r:id="R37cb9b78764d4331"/>
-    <p:sldId xmlns:r="http://schemas.openxmlformats.org/officeDocument/2006/relationships" id="260" r:id="Rd111a36d9ffd4c20"/>
-    <p:sldId xmlns:r="http://schemas.openxmlformats.org/officeDocument/2006/relationships" id="261" r:id="R6ea5ae5ba7604909"/>
+    <p:sldId xmlns:r="http://schemas.openxmlformats.org/officeDocument/2006/relationships" id="256" r:id="R4191fa74385d4697"/>
+    <p:sldId xmlns:r="http://schemas.openxmlformats.org/officeDocument/2006/relationships" id="257" r:id="R165edb056e3f4953"/>
+    <p:sldId xmlns:r="http://schemas.openxmlformats.org/officeDocument/2006/relationships" id="258" r:id="Rcfa41bdd4dbe4bba"/>
+    <p:sldId xmlns:r="http://schemas.openxmlformats.org/officeDocument/2006/relationships" id="259" r:id="Rfcaeedb8c194451a"/>
+    <p:sldId xmlns:r="http://schemas.openxmlformats.org/officeDocument/2006/relationships" id="260" r:id="Rbfe692b57d7f4570"/>
+    <p:sldId xmlns:r="http://schemas.openxmlformats.org/officeDocument/2006/relationships" id="261" r:id="R88cc1523a1214b4f"/>
   </p:sldIdLst>
   <p:sldSz cx="12192000" cy="6858000"/>
   <p:notesSz cx="6858000" cy="9144000"/>
@@ -985,7 +985,7 @@
   </p:cSld>
   <p:clrMap bg1="lt1" tx1="dk1" bg2="lt2" tx2="dk2" accent1="accent1" accent2="accent2" accent3="accent3" accent4="accent4" accent5="accent5" accent6="accent6" hlink="hlink" folHlink="folHlink"/>
   <p:sldLayoutIdLst>
-    <p:sldLayoutId xmlns:r="http://schemas.openxmlformats.org/officeDocument/2006/relationships" id="2147483649" r:id="Rf29b93aedff14eb5"/>
+    <p:sldLayoutId xmlns:r="http://schemas.openxmlformats.org/officeDocument/2006/relationships" id="2147483649" r:id="Rf470d6474d974512"/>
   </p:sldLayoutIdLst>
   <p:txStyles>
     <p:titleStyle>
@@ -1540,10 +1540,10 @@
           <p:nvPr/>
         </p:nvPicPr>
         <p:blipFill>
-          <a:blip xmlns:r="http://schemas.openxmlformats.org/officeDocument/2006/relationships" xmlns:a="http://schemas.openxmlformats.org/drawingml/2006/main" r:embed="R26620d7e679a49f4">
+          <a:blip xmlns:r="http://schemas.openxmlformats.org/officeDocument/2006/relationships" xmlns:a="http://schemas.openxmlformats.org/drawingml/2006/main" r:embed="R7b665fb27e874ed7">
             <a:extLst>
               <a:ext uri="{96DAC541-7B7A-43D3-8B79-37D633B846F1}">
-                <asvg:svgBlip xmlns:asvg="http://schemas.microsoft.com/office/drawing/2016/SVG/main" r:embed="Ra108a5d933564bde"/>
+                <asvg:svgBlip xmlns:asvg="http://schemas.microsoft.com/office/drawing/2016/SVG/main" r:embed="R87095b5f95984d5f"/>
               </a:ext>
             </a:extLst>
           </a:blip>
@@ -1564,7 +1564,7 @@
           <p:cNvPr id="2" name="rule-78-176">
             <a:extLst xmlns:a="http://schemas.openxmlformats.org/drawingml/2006/main">
               <a:ext uri="{FF2B5EF4-FFF2-40B4-BE49-F238E27FC236}">
-                <a16:creationId xmlns:a16="http://schemas.microsoft.com/office/drawing/2014/main" id="{D9930CD0-5D04-452E-8E99-ACA77B40BC2F}"/>
+                <a16:creationId xmlns:a16="http://schemas.microsoft.com/office/drawing/2014/main" id="{B21BA506-DE5D-41EB-94D4-49F5F3E21AC2}"/>
               </a:ext>
             </a:extLst>
           </p:cNvPr>
@@ -1595,7 +1595,7 @@
           <p:cNvPr id="3" name="title">
             <a:extLst xmlns:a="http://schemas.openxmlformats.org/drawingml/2006/main">
               <a:ext uri="{FF2B5EF4-FFF2-40B4-BE49-F238E27FC236}">
-                <a16:creationId xmlns:a16="http://schemas.microsoft.com/office/drawing/2014/main" id="{0F37F8B0-1189-459C-A659-29248F4C20F2}"/>
+                <a16:creationId xmlns:a16="http://schemas.microsoft.com/office/drawing/2014/main" id="{203D677D-8C0D-410C-BCA5-BFD5DD09AD2D}"/>
               </a:ext>
             </a:extLst>
           </p:cNvPr>
@@ -1662,7 +1662,7 @@
           <p:cNvPr id="4" name="subtitle">
             <a:extLst xmlns:a="http://schemas.openxmlformats.org/drawingml/2006/main">
               <a:ext uri="{FF2B5EF4-FFF2-40B4-BE49-F238E27FC236}">
-                <a16:creationId xmlns:a16="http://schemas.microsoft.com/office/drawing/2014/main" id="{C5B5711C-2FD8-41CD-953A-7480B7A7CB98}"/>
+                <a16:creationId xmlns:a16="http://schemas.microsoft.com/office/drawing/2014/main" id="{44B5E2D6-A8EF-4E48-B896-FD30373CC01F}"/>
               </a:ext>
             </a:extLst>
           </p:cNvPr>
@@ -1712,7 +1712,7 @@
           <p:cNvPr id="5" name="version">
             <a:extLst xmlns:a="http://schemas.openxmlformats.org/drawingml/2006/main">
               <a:ext uri="{FF2B5EF4-FFF2-40B4-BE49-F238E27FC236}">
-                <a16:creationId xmlns:a16="http://schemas.microsoft.com/office/drawing/2014/main" id="{BD0F9BAF-1CAE-4A75-AA8B-8E0392206F79}"/>
+                <a16:creationId xmlns:a16="http://schemas.microsoft.com/office/drawing/2014/main" id="{09844E02-6F5D-4662-8AB2-FEBB9A48F5C8}"/>
               </a:ext>
             </a:extLst>
           </p:cNvPr>
@@ -1766,10 +1766,10 @@
           <p:nvPr/>
         </p:nvPicPr>
         <p:blipFill>
-          <a:blip xmlns:r="http://schemas.openxmlformats.org/officeDocument/2006/relationships" xmlns:a="http://schemas.openxmlformats.org/drawingml/2006/main" r:embed="R223eb48edd0a46f1">
+          <a:blip xmlns:r="http://schemas.openxmlformats.org/officeDocument/2006/relationships" xmlns:a="http://schemas.openxmlformats.org/drawingml/2006/main" r:embed="Re6e357161a9e47d4">
             <a:extLst>
               <a:ext uri="{96DAC541-7B7A-43D3-8B79-37D633B846F1}">
-                <asvg:svgBlip xmlns:asvg="http://schemas.microsoft.com/office/drawing/2016/SVG/main" r:embed="Rbbe5a2e5cb214904"/>
+                <asvg:svgBlip xmlns:asvg="http://schemas.microsoft.com/office/drawing/2016/SVG/main" r:embed="R5191dad934bc4fd6"/>
               </a:ext>
             </a:extLst>
           </a:blip>
@@ -1788,7 +1788,7 @@
     </p:spTree>
     <p:extLst>
       <p:ext uri="{BB962C8B-B14F-4D97-AF65-F5344CB8AC3E}">
-        <p14:creationId xmlns:p14="http://schemas.microsoft.com/office/powerpoint/2010/main" val="1979705523"/>
+        <p14:creationId xmlns:p14="http://schemas.microsoft.com/office/powerpoint/2010/main" val="790141864"/>
       </p:ext>
     </p:extLst>
   </p:cSld>
@@ -1823,10 +1823,10 @@
           <p:nvPr/>
         </p:nvPicPr>
         <p:blipFill>
-          <a:blip xmlns:r="http://schemas.openxmlformats.org/officeDocument/2006/relationships" xmlns:a="http://schemas.openxmlformats.org/drawingml/2006/main" r:embed="R1d307f2d55d24764">
+          <a:blip xmlns:r="http://schemas.openxmlformats.org/officeDocument/2006/relationships" xmlns:a="http://schemas.openxmlformats.org/drawingml/2006/main" r:embed="Rcef4e9b1bf2b4b7b">
             <a:extLst>
               <a:ext uri="{96DAC541-7B7A-43D3-8B79-37D633B846F1}">
-                <asvg:svgBlip xmlns:asvg="http://schemas.microsoft.com/office/drawing/2016/SVG/main" r:embed="Rad2397cb4b3a4d3c"/>
+                <asvg:svgBlip xmlns:asvg="http://schemas.microsoft.com/office/drawing/2016/SVG/main" r:embed="R71d58505b6e74c89"/>
               </a:ext>
             </a:extLst>
           </a:blip>
@@ -1847,7 +1847,7 @@
           <p:cNvPr id="2" name="eyebrow">
             <a:extLst xmlns:a="http://schemas.openxmlformats.org/drawingml/2006/main">
               <a:ext uri="{FF2B5EF4-FFF2-40B4-BE49-F238E27FC236}">
-                <a16:creationId xmlns:a16="http://schemas.microsoft.com/office/drawing/2014/main" id="{A56EDABD-7FED-437D-8BBA-F84BCB8AE802}"/>
+                <a16:creationId xmlns:a16="http://schemas.microsoft.com/office/drawing/2014/main" id="{43009C28-9271-4CEF-AC23-58C18181F963}"/>
               </a:ext>
             </a:extLst>
           </p:cNvPr>
@@ -1897,7 +1897,7 @@
           <p:cNvPr id="3" name="title">
             <a:extLst xmlns:a="http://schemas.openxmlformats.org/drawingml/2006/main">
               <a:ext uri="{FF2B5EF4-FFF2-40B4-BE49-F238E27FC236}">
-                <a16:creationId xmlns:a16="http://schemas.microsoft.com/office/drawing/2014/main" id="{0518C33D-FDE6-4FBF-A1C7-9C22942C25E5}"/>
+                <a16:creationId xmlns:a16="http://schemas.microsoft.com/office/drawing/2014/main" id="{1687D8E1-687E-4CA9-8B4B-3A84AACFEA4C}"/>
               </a:ext>
             </a:extLst>
           </p:cNvPr>
@@ -1964,7 +1964,7 @@
           <p:cNvPr id="4" name="body">
             <a:extLst xmlns:a="http://schemas.openxmlformats.org/drawingml/2006/main">
               <a:ext uri="{FF2B5EF4-FFF2-40B4-BE49-F238E27FC236}">
-                <a16:creationId xmlns:a16="http://schemas.microsoft.com/office/drawing/2014/main" id="{74875CF1-4610-4B7C-8B1F-C56D14A26876}"/>
+                <a16:creationId xmlns:a16="http://schemas.microsoft.com/office/drawing/2014/main" id="{C74C8A5F-F4C7-4AA6-BD99-4CF8C51155BE}"/>
               </a:ext>
             </a:extLst>
           </p:cNvPr>
@@ -2014,7 +2014,7 @@
           <p:cNvPr id="5" name="violet-field">
             <a:extLst xmlns:a="http://schemas.openxmlformats.org/drawingml/2006/main">
               <a:ext uri="{FF2B5EF4-FFF2-40B4-BE49-F238E27FC236}">
-                <a16:creationId xmlns:a16="http://schemas.microsoft.com/office/drawing/2014/main" id="{C2AE80AE-7487-4A72-9ABB-61FA795F46DD}"/>
+                <a16:creationId xmlns:a16="http://schemas.microsoft.com/office/drawing/2014/main" id="{82C6464C-B0CF-4FEC-A35F-39BFD9849A0D}"/>
               </a:ext>
             </a:extLst>
           </p:cNvPr>
@@ -2049,10 +2049,10 @@
           <p:nvPr/>
         </p:nvPicPr>
         <p:blipFill>
-          <a:blip xmlns:r="http://schemas.openxmlformats.org/officeDocument/2006/relationships" xmlns:a="http://schemas.openxmlformats.org/drawingml/2006/main" r:embed="Rb87b57bf03ca45f4">
+          <a:blip xmlns:r="http://schemas.openxmlformats.org/officeDocument/2006/relationships" xmlns:a="http://schemas.openxmlformats.org/drawingml/2006/main" r:embed="R5aae8f6f6f904377">
             <a:extLst>
               <a:ext uri="{96DAC541-7B7A-43D3-8B79-37D633B846F1}">
-                <asvg:svgBlip xmlns:asvg="http://schemas.microsoft.com/office/drawing/2016/SVG/main" r:embed="R71f12fe6c82d4e80"/>
+                <asvg:svgBlip xmlns:asvg="http://schemas.microsoft.com/office/drawing/2016/SVG/main" r:embed="Ra90ba560e8274046"/>
               </a:ext>
             </a:extLst>
           </a:blip>
@@ -2073,7 +2073,7 @@
           <p:cNvPr id="7" name="rule-954-0">
             <a:extLst xmlns:a="http://schemas.openxmlformats.org/drawingml/2006/main">
               <a:ext uri="{FF2B5EF4-FFF2-40B4-BE49-F238E27FC236}">
-                <a16:creationId xmlns:a16="http://schemas.microsoft.com/office/drawing/2014/main" id="{219D2060-0B07-49FA-94C6-6A55266000F3}"/>
+                <a16:creationId xmlns:a16="http://schemas.microsoft.com/office/drawing/2014/main" id="{037F70A9-8D89-4E44-B360-C688D317F20C}"/>
               </a:ext>
             </a:extLst>
           </p:cNvPr>
@@ -2102,7 +2102,7 @@
     </p:spTree>
     <p:extLst>
       <p:ext uri="{BB962C8B-B14F-4D97-AF65-F5344CB8AC3E}">
-        <p14:creationId xmlns:p14="http://schemas.microsoft.com/office/powerpoint/2010/main" val="751728159"/>
+        <p14:creationId xmlns:p14="http://schemas.microsoft.com/office/powerpoint/2010/main" val="902052242"/>
       </p:ext>
     </p:extLst>
   </p:cSld>
@@ -2137,10 +2137,10 @@
           <p:nvPr/>
         </p:nvPicPr>
         <p:blipFill>
-          <a:blip xmlns:r="http://schemas.openxmlformats.org/officeDocument/2006/relationships" xmlns:a="http://schemas.openxmlformats.org/drawingml/2006/main" r:embed="R2ef28d1d70064346">
+          <a:blip xmlns:r="http://schemas.openxmlformats.org/officeDocument/2006/relationships" xmlns:a="http://schemas.openxmlformats.org/drawingml/2006/main" r:embed="R4af834c9d53a404b">
             <a:extLst>
               <a:ext uri="{96DAC541-7B7A-43D3-8B79-37D633B846F1}">
-                <asvg:svgBlip xmlns:asvg="http://schemas.microsoft.com/office/drawing/2016/SVG/main" r:embed="R04eec531b2f24511"/>
+                <asvg:svgBlip xmlns:asvg="http://schemas.microsoft.com/office/drawing/2016/SVG/main" r:embed="Rb3962f24a40646d3"/>
               </a:ext>
             </a:extLst>
           </a:blip>
@@ -2161,7 +2161,7 @@
           <p:cNvPr id="2" name="title">
             <a:extLst xmlns:a="http://schemas.openxmlformats.org/drawingml/2006/main">
               <a:ext uri="{FF2B5EF4-FFF2-40B4-BE49-F238E27FC236}">
-                <a16:creationId xmlns:a16="http://schemas.microsoft.com/office/drawing/2014/main" id="{7E6F71D8-78C5-4420-8CF6-88F1DBE8DB0A}"/>
+                <a16:creationId xmlns:a16="http://schemas.microsoft.com/office/drawing/2014/main" id="{1164ACB6-2260-4282-B620-DFD1BD55A1DA}"/>
               </a:ext>
             </a:extLst>
           </p:cNvPr>
@@ -2211,7 +2211,7 @@
           <p:cNvPr id="3" name="number-0">
             <a:extLst xmlns:a="http://schemas.openxmlformats.org/drawingml/2006/main">
               <a:ext uri="{FF2B5EF4-FFF2-40B4-BE49-F238E27FC236}">
-                <a16:creationId xmlns:a16="http://schemas.microsoft.com/office/drawing/2014/main" id="{35E62E7B-0723-4ECF-82DE-45F3DA0D93D3}"/>
+                <a16:creationId xmlns:a16="http://schemas.microsoft.com/office/drawing/2014/main" id="{4B8419FA-1FCA-467B-8A95-85999E48882F}"/>
               </a:ext>
             </a:extLst>
           </p:cNvPr>
@@ -2261,7 +2261,7 @@
           <p:cNvPr id="4" name="heading-0">
             <a:extLst xmlns:a="http://schemas.openxmlformats.org/drawingml/2006/main">
               <a:ext uri="{FF2B5EF4-FFF2-40B4-BE49-F238E27FC236}">
-                <a16:creationId xmlns:a16="http://schemas.microsoft.com/office/drawing/2014/main" id="{CBB92FE8-FDBC-445A-84AA-5731A2E0D04F}"/>
+                <a16:creationId xmlns:a16="http://schemas.microsoft.com/office/drawing/2014/main" id="{A399A21D-C823-4F21-A992-D7134338A537}"/>
               </a:ext>
             </a:extLst>
           </p:cNvPr>
@@ -2311,7 +2311,7 @@
           <p:cNvPr id="5" name="body-0">
             <a:extLst xmlns:a="http://schemas.openxmlformats.org/drawingml/2006/main">
               <a:ext uri="{FF2B5EF4-FFF2-40B4-BE49-F238E27FC236}">
-                <a16:creationId xmlns:a16="http://schemas.microsoft.com/office/drawing/2014/main" id="{2FCE2CDD-DE82-41F0-812A-1DF6EF11A485}"/>
+                <a16:creationId xmlns:a16="http://schemas.microsoft.com/office/drawing/2014/main" id="{26532BDA-14CC-4448-92DB-1B713655C086}"/>
               </a:ext>
             </a:extLst>
           </p:cNvPr>
@@ -2361,7 +2361,7 @@
           <p:cNvPr id="6" name="divider-1">
             <a:extLst xmlns:a="http://schemas.openxmlformats.org/drawingml/2006/main">
               <a:ext uri="{FF2B5EF4-FFF2-40B4-BE49-F238E27FC236}">
-                <a16:creationId xmlns:a16="http://schemas.microsoft.com/office/drawing/2014/main" id="{5E18BA9B-43DC-41FD-8C23-457ED0E219F0}"/>
+                <a16:creationId xmlns:a16="http://schemas.microsoft.com/office/drawing/2014/main" id="{59F5D5A7-0636-43F1-AD3A-2B8E489ED18C}"/>
               </a:ext>
             </a:extLst>
           </p:cNvPr>
@@ -2392,7 +2392,7 @@
           <p:cNvPr id="7" name="number-1">
             <a:extLst xmlns:a="http://schemas.openxmlformats.org/drawingml/2006/main">
               <a:ext uri="{FF2B5EF4-FFF2-40B4-BE49-F238E27FC236}">
-                <a16:creationId xmlns:a16="http://schemas.microsoft.com/office/drawing/2014/main" id="{7E299979-A4C8-450E-BACC-6389699A4987}"/>
+                <a16:creationId xmlns:a16="http://schemas.microsoft.com/office/drawing/2014/main" id="{C11AF78E-0BA0-4F94-8A46-91EC691CF3AE}"/>
               </a:ext>
             </a:extLst>
           </p:cNvPr>
@@ -2442,7 +2442,7 @@
           <p:cNvPr id="8" name="heading-1">
             <a:extLst xmlns:a="http://schemas.openxmlformats.org/drawingml/2006/main">
               <a:ext uri="{FF2B5EF4-FFF2-40B4-BE49-F238E27FC236}">
-                <a16:creationId xmlns:a16="http://schemas.microsoft.com/office/drawing/2014/main" id="{CEBF6112-1266-44B2-8E53-4DE15ED55E9E}"/>
+                <a16:creationId xmlns:a16="http://schemas.microsoft.com/office/drawing/2014/main" id="{F81498D9-773A-431E-BB6A-5F72DFDCEC21}"/>
               </a:ext>
             </a:extLst>
           </p:cNvPr>
@@ -2492,7 +2492,7 @@
           <p:cNvPr id="9" name="body-1">
             <a:extLst xmlns:a="http://schemas.openxmlformats.org/drawingml/2006/main">
               <a:ext uri="{FF2B5EF4-FFF2-40B4-BE49-F238E27FC236}">
-                <a16:creationId xmlns:a16="http://schemas.microsoft.com/office/drawing/2014/main" id="{259BCA3A-DAD0-43AA-A710-D73DEE035D86}"/>
+                <a16:creationId xmlns:a16="http://schemas.microsoft.com/office/drawing/2014/main" id="{DD2F1FA4-E8C7-4A5A-8131-77CCF1A66EDA}"/>
               </a:ext>
             </a:extLst>
           </p:cNvPr>
@@ -2542,7 +2542,7 @@
           <p:cNvPr id="10" name="divider-2">
             <a:extLst xmlns:a="http://schemas.openxmlformats.org/drawingml/2006/main">
               <a:ext uri="{FF2B5EF4-FFF2-40B4-BE49-F238E27FC236}">
-                <a16:creationId xmlns:a16="http://schemas.microsoft.com/office/drawing/2014/main" id="{50956E94-EF67-44F4-942A-6885BAF0163A}"/>
+                <a16:creationId xmlns:a16="http://schemas.microsoft.com/office/drawing/2014/main" id="{FF53CBD6-CBC5-4FFC-A883-68A4BECF2FF2}"/>
               </a:ext>
             </a:extLst>
           </p:cNvPr>
@@ -2573,7 +2573,7 @@
           <p:cNvPr id="11" name="number-2">
             <a:extLst xmlns:a="http://schemas.openxmlformats.org/drawingml/2006/main">
               <a:ext uri="{FF2B5EF4-FFF2-40B4-BE49-F238E27FC236}">
-                <a16:creationId xmlns:a16="http://schemas.microsoft.com/office/drawing/2014/main" id="{47C471A9-D25B-4AB6-A805-A12CD45E2036}"/>
+                <a16:creationId xmlns:a16="http://schemas.microsoft.com/office/drawing/2014/main" id="{7A1B0178-7C01-4A6E-9DB0-DE8B0F545308}"/>
               </a:ext>
             </a:extLst>
           </p:cNvPr>
@@ -2623,7 +2623,7 @@
           <p:cNvPr id="12" name="heading-2">
             <a:extLst xmlns:a="http://schemas.openxmlformats.org/drawingml/2006/main">
               <a:ext uri="{FF2B5EF4-FFF2-40B4-BE49-F238E27FC236}">
-                <a16:creationId xmlns:a16="http://schemas.microsoft.com/office/drawing/2014/main" id="{4C70A32A-E1EC-4C10-B529-D0B35AD83275}"/>
+                <a16:creationId xmlns:a16="http://schemas.microsoft.com/office/drawing/2014/main" id="{9ED24F63-CB71-4FFD-A96A-A7BFD4EB9209}"/>
               </a:ext>
             </a:extLst>
           </p:cNvPr>
@@ -2673,7 +2673,7 @@
           <p:cNvPr id="13" name="body-2">
             <a:extLst xmlns:a="http://schemas.openxmlformats.org/drawingml/2006/main">
               <a:ext uri="{FF2B5EF4-FFF2-40B4-BE49-F238E27FC236}">
-                <a16:creationId xmlns:a16="http://schemas.microsoft.com/office/drawing/2014/main" id="{A8F0A3F4-9C6A-4A82-896B-CF18DB5BC67A}"/>
+                <a16:creationId xmlns:a16="http://schemas.microsoft.com/office/drawing/2014/main" id="{6332B98B-BC6F-4684-8026-DC053173E603}"/>
               </a:ext>
             </a:extLst>
           </p:cNvPr>
@@ -2723,7 +2723,7 @@
           <p:cNvPr id="14" name="rule-76-596">
             <a:extLst xmlns:a="http://schemas.openxmlformats.org/drawingml/2006/main">
               <a:ext uri="{FF2B5EF4-FFF2-40B4-BE49-F238E27FC236}">
-                <a16:creationId xmlns:a16="http://schemas.microsoft.com/office/drawing/2014/main" id="{947ADF3E-D4C2-479C-9A1B-E6E155E21D28}"/>
+                <a16:creationId xmlns:a16="http://schemas.microsoft.com/office/drawing/2014/main" id="{A8578A19-10FC-4A8A-9E8C-6689BEECCB72}"/>
               </a:ext>
             </a:extLst>
           </p:cNvPr>
@@ -2754,7 +2754,7 @@
           <p:cNvPr id="15" name="footer">
             <a:extLst xmlns:a="http://schemas.openxmlformats.org/drawingml/2006/main">
               <a:ext uri="{FF2B5EF4-FFF2-40B4-BE49-F238E27FC236}">
-                <a16:creationId xmlns:a16="http://schemas.microsoft.com/office/drawing/2014/main" id="{D9C284C2-2668-4AB3-8F5E-97D5DBCDD842}"/>
+                <a16:creationId xmlns:a16="http://schemas.microsoft.com/office/drawing/2014/main" id="{28C118D5-F18B-4E14-9353-5DA2FC57DCF8}"/>
               </a:ext>
             </a:extLst>
           </p:cNvPr>
@@ -2802,7 +2802,7 @@
     </p:spTree>
     <p:extLst>
       <p:ext uri="{BB962C8B-B14F-4D97-AF65-F5344CB8AC3E}">
-        <p14:creationId xmlns:p14="http://schemas.microsoft.com/office/powerpoint/2010/main" val="1700539768"/>
+        <p14:creationId xmlns:p14="http://schemas.microsoft.com/office/powerpoint/2010/main" val="1531960450"/>
       </p:ext>
     </p:extLst>
   </p:cSld>
@@ -2837,10 +2837,10 @@
           <p:nvPr/>
         </p:nvPicPr>
         <p:blipFill>
-          <a:blip xmlns:r="http://schemas.openxmlformats.org/officeDocument/2006/relationships" xmlns:a="http://schemas.openxmlformats.org/drawingml/2006/main" r:embed="R5223fea1037a4cb9">
+          <a:blip xmlns:r="http://schemas.openxmlformats.org/officeDocument/2006/relationships" xmlns:a="http://schemas.openxmlformats.org/drawingml/2006/main" r:embed="Rc4dc8a50d85d4538">
             <a:extLst>
               <a:ext uri="{96DAC541-7B7A-43D3-8B79-37D633B846F1}">
-                <asvg:svgBlip xmlns:asvg="http://schemas.microsoft.com/office/drawing/2016/SVG/main" r:embed="R93acb1f417cb40c3"/>
+                <asvg:svgBlip xmlns:asvg="http://schemas.microsoft.com/office/drawing/2016/SVG/main" r:embed="Rd5fdc9b1f5954d0d"/>
               </a:ext>
             </a:extLst>
           </a:blip>
@@ -2861,7 +2861,7 @@
           <p:cNvPr id="2" name="title">
             <a:extLst xmlns:a="http://schemas.openxmlformats.org/drawingml/2006/main">
               <a:ext uri="{FF2B5EF4-FFF2-40B4-BE49-F238E27FC236}">
-                <a16:creationId xmlns:a16="http://schemas.microsoft.com/office/drawing/2014/main" id="{3A575991-59D5-4398-858F-9C314D5FB953}"/>
+                <a16:creationId xmlns:a16="http://schemas.microsoft.com/office/drawing/2014/main" id="{0CC485F2-82C0-405C-BE22-E4774D6AB510}"/>
               </a:ext>
             </a:extLst>
           </p:cNvPr>
@@ -2911,7 +2911,7 @@
           <p:cNvPr id="3" name="stage-0">
             <a:extLst xmlns:a="http://schemas.openxmlformats.org/drawingml/2006/main">
               <a:ext uri="{FF2B5EF4-FFF2-40B4-BE49-F238E27FC236}">
-                <a16:creationId xmlns:a16="http://schemas.microsoft.com/office/drawing/2014/main" id="{6AF5F4C0-F026-408C-B352-FC771A036BA7}"/>
+                <a16:creationId xmlns:a16="http://schemas.microsoft.com/office/drawing/2014/main" id="{A87217FB-E0E0-495F-B44B-E53511DF7A6D}"/>
               </a:ext>
             </a:extLst>
           </p:cNvPr>
@@ -2946,7 +2946,7 @@
           <p:cNvPr id="4" name="stage-title-0">
             <a:extLst xmlns:a="http://schemas.openxmlformats.org/drawingml/2006/main">
               <a:ext uri="{FF2B5EF4-FFF2-40B4-BE49-F238E27FC236}">
-                <a16:creationId xmlns:a16="http://schemas.microsoft.com/office/drawing/2014/main" id="{05DEB4F9-A396-464C-B3A1-BD722834D347}"/>
+                <a16:creationId xmlns:a16="http://schemas.microsoft.com/office/drawing/2014/main" id="{5C989AE1-1727-4DD1-BDB0-AC9C5045ECF5}"/>
               </a:ext>
             </a:extLst>
           </p:cNvPr>
@@ -2996,7 +2996,7 @@
           <p:cNvPr id="5" name="stage-body-0">
             <a:extLst xmlns:a="http://schemas.openxmlformats.org/drawingml/2006/main">
               <a:ext uri="{FF2B5EF4-FFF2-40B4-BE49-F238E27FC236}">
-                <a16:creationId xmlns:a16="http://schemas.microsoft.com/office/drawing/2014/main" id="{A35771BE-2E1E-45E8-87BF-839A0D8EEB17}"/>
+                <a16:creationId xmlns:a16="http://schemas.microsoft.com/office/drawing/2014/main" id="{4C182CCF-B4FC-4E83-88F7-9976A08D8138}"/>
               </a:ext>
             </a:extLst>
           </p:cNvPr>
@@ -3046,7 +3046,7 @@
           <p:cNvPr id="6" name="connector-0">
             <a:extLst xmlns:a="http://schemas.openxmlformats.org/drawingml/2006/main">
               <a:ext uri="{FF2B5EF4-FFF2-40B4-BE49-F238E27FC236}">
-                <a16:creationId xmlns:a16="http://schemas.microsoft.com/office/drawing/2014/main" id="{90411143-8328-4A6E-843D-489B9037EBB2}"/>
+                <a16:creationId xmlns:a16="http://schemas.microsoft.com/office/drawing/2014/main" id="{2DE4D836-AA57-4138-9DB3-E21CEDC62F0C}"/>
               </a:ext>
             </a:extLst>
           </p:cNvPr>
@@ -3077,7 +3077,7 @@
           <p:cNvPr id="7" name="arrow-0">
             <a:extLst xmlns:a="http://schemas.openxmlformats.org/drawingml/2006/main">
               <a:ext uri="{FF2B5EF4-FFF2-40B4-BE49-F238E27FC236}">
-                <a16:creationId xmlns:a16="http://schemas.microsoft.com/office/drawing/2014/main" id="{398921EC-2765-4C69-8762-632D7C3285CC}"/>
+                <a16:creationId xmlns:a16="http://schemas.microsoft.com/office/drawing/2014/main" id="{9A09DB05-8A9B-4815-9F19-26D1855A6CE5}"/>
               </a:ext>
             </a:extLst>
           </p:cNvPr>
@@ -3108,7 +3108,7 @@
           <p:cNvPr id="8" name="stage-1">
             <a:extLst xmlns:a="http://schemas.openxmlformats.org/drawingml/2006/main">
               <a:ext uri="{FF2B5EF4-FFF2-40B4-BE49-F238E27FC236}">
-                <a16:creationId xmlns:a16="http://schemas.microsoft.com/office/drawing/2014/main" id="{2C9850CE-B628-4ED0-9F9C-5F4452534F5B}"/>
+                <a16:creationId xmlns:a16="http://schemas.microsoft.com/office/drawing/2014/main" id="{8B36AF75-1FB3-49F6-B982-11C8B7D1E178}"/>
               </a:ext>
             </a:extLst>
           </p:cNvPr>
@@ -3143,7 +3143,7 @@
           <p:cNvPr id="9" name="stage-title-1">
             <a:extLst xmlns:a="http://schemas.openxmlformats.org/drawingml/2006/main">
               <a:ext uri="{FF2B5EF4-FFF2-40B4-BE49-F238E27FC236}">
-                <a16:creationId xmlns:a16="http://schemas.microsoft.com/office/drawing/2014/main" id="{EF0AF388-7CBD-4653-B910-5DABA2755142}"/>
+                <a16:creationId xmlns:a16="http://schemas.microsoft.com/office/drawing/2014/main" id="{77D9B633-5964-44BD-B697-BFC8EEF208ED}"/>
               </a:ext>
             </a:extLst>
           </p:cNvPr>
@@ -3193,7 +3193,7 @@
           <p:cNvPr id="10" name="stage-body-1">
             <a:extLst xmlns:a="http://schemas.openxmlformats.org/drawingml/2006/main">
               <a:ext uri="{FF2B5EF4-FFF2-40B4-BE49-F238E27FC236}">
-                <a16:creationId xmlns:a16="http://schemas.microsoft.com/office/drawing/2014/main" id="{94B9A742-4661-4D0F-854F-C0AF65F6DC2D}"/>
+                <a16:creationId xmlns:a16="http://schemas.microsoft.com/office/drawing/2014/main" id="{5F9CBFA7-134D-40BE-A677-107413F42C42}"/>
               </a:ext>
             </a:extLst>
           </p:cNvPr>
@@ -3243,7 +3243,7 @@
           <p:cNvPr id="11" name="connector-1">
             <a:extLst xmlns:a="http://schemas.openxmlformats.org/drawingml/2006/main">
               <a:ext uri="{FF2B5EF4-FFF2-40B4-BE49-F238E27FC236}">
-                <a16:creationId xmlns:a16="http://schemas.microsoft.com/office/drawing/2014/main" id="{58702B25-6CF3-426D-93AB-96CAD4554274}"/>
+                <a16:creationId xmlns:a16="http://schemas.microsoft.com/office/drawing/2014/main" id="{98519390-01C8-4D5F-9F84-495A267558EB}"/>
               </a:ext>
             </a:extLst>
           </p:cNvPr>
@@ -3274,7 +3274,7 @@
           <p:cNvPr id="12" name="arrow-1">
             <a:extLst xmlns:a="http://schemas.openxmlformats.org/drawingml/2006/main">
               <a:ext uri="{FF2B5EF4-FFF2-40B4-BE49-F238E27FC236}">
-                <a16:creationId xmlns:a16="http://schemas.microsoft.com/office/drawing/2014/main" id="{4078F585-24FC-4162-AD8B-57E70DD44AE4}"/>
+                <a16:creationId xmlns:a16="http://schemas.microsoft.com/office/drawing/2014/main" id="{5ED64213-4D2A-422D-992E-53CF884C16B4}"/>
               </a:ext>
             </a:extLst>
           </p:cNvPr>
@@ -3305,7 +3305,7 @@
           <p:cNvPr id="13" name="stage-2">
             <a:extLst xmlns:a="http://schemas.openxmlformats.org/drawingml/2006/main">
               <a:ext uri="{FF2B5EF4-FFF2-40B4-BE49-F238E27FC236}">
-                <a16:creationId xmlns:a16="http://schemas.microsoft.com/office/drawing/2014/main" id="{B04AC4A5-6439-44E5-BA4F-6EDECE05A014}"/>
+                <a16:creationId xmlns:a16="http://schemas.microsoft.com/office/drawing/2014/main" id="{3AB07B39-4700-48A3-B1FF-F20794212DA1}"/>
               </a:ext>
             </a:extLst>
           </p:cNvPr>
@@ -3340,7 +3340,7 @@
           <p:cNvPr id="14" name="stage-title-2">
             <a:extLst xmlns:a="http://schemas.openxmlformats.org/drawingml/2006/main">
               <a:ext uri="{FF2B5EF4-FFF2-40B4-BE49-F238E27FC236}">
-                <a16:creationId xmlns:a16="http://schemas.microsoft.com/office/drawing/2014/main" id="{841CDD17-B5F8-42A2-84DC-81A33AD3D21A}"/>
+                <a16:creationId xmlns:a16="http://schemas.microsoft.com/office/drawing/2014/main" id="{C1FA92ED-12C4-4CE9-8303-C66730BE9C49}"/>
               </a:ext>
             </a:extLst>
           </p:cNvPr>
@@ -3390,7 +3390,7 @@
           <p:cNvPr id="15" name="stage-body-2">
             <a:extLst xmlns:a="http://schemas.openxmlformats.org/drawingml/2006/main">
               <a:ext uri="{FF2B5EF4-FFF2-40B4-BE49-F238E27FC236}">
-                <a16:creationId xmlns:a16="http://schemas.microsoft.com/office/drawing/2014/main" id="{EDC4CE44-8B35-4B15-93FD-309AFC83C66D}"/>
+                <a16:creationId xmlns:a16="http://schemas.microsoft.com/office/drawing/2014/main" id="{06103F54-7CD4-48EA-8EF8-9184B1699A9E}"/>
               </a:ext>
             </a:extLst>
           </p:cNvPr>
@@ -3440,7 +3440,7 @@
           <p:cNvPr id="16" name="caption">
             <a:extLst xmlns:a="http://schemas.openxmlformats.org/drawingml/2006/main">
               <a:ext uri="{FF2B5EF4-FFF2-40B4-BE49-F238E27FC236}">
-                <a16:creationId xmlns:a16="http://schemas.microsoft.com/office/drawing/2014/main" id="{7EEAEF9F-1E8E-4DE4-8149-7D274B8E109E}"/>
+                <a16:creationId xmlns:a16="http://schemas.microsoft.com/office/drawing/2014/main" id="{C9615C68-99ED-4091-908F-799C6684AE00}"/>
               </a:ext>
             </a:extLst>
           </p:cNvPr>
@@ -3490,7 +3490,7 @@
           <p:cNvPr id="17" name="support">
             <a:extLst xmlns:a="http://schemas.openxmlformats.org/drawingml/2006/main">
               <a:ext uri="{FF2B5EF4-FFF2-40B4-BE49-F238E27FC236}">
-                <a16:creationId xmlns:a16="http://schemas.microsoft.com/office/drawing/2014/main" id="{273E16D3-A8E8-4071-8E6F-5AEE6CCC92A5}"/>
+                <a16:creationId xmlns:a16="http://schemas.microsoft.com/office/drawing/2014/main" id="{9869DC45-1750-46E3-A208-D9B8927ECA00}"/>
               </a:ext>
             </a:extLst>
           </p:cNvPr>
@@ -3538,7 +3538,7 @@
     </p:spTree>
     <p:extLst>
       <p:ext uri="{BB962C8B-B14F-4D97-AF65-F5344CB8AC3E}">
-        <p14:creationId xmlns:p14="http://schemas.microsoft.com/office/powerpoint/2010/main" val="950149345"/>
+        <p14:creationId xmlns:p14="http://schemas.microsoft.com/office/powerpoint/2010/main" val="1877921793"/>
       </p:ext>
     </p:extLst>
   </p:cSld>
@@ -3573,10 +3573,10 @@
           <p:nvPr/>
         </p:nvPicPr>
         <p:blipFill>
-          <a:blip xmlns:r="http://schemas.openxmlformats.org/officeDocument/2006/relationships" xmlns:a="http://schemas.openxmlformats.org/drawingml/2006/main" r:embed="R47e94aa8ea3949e6">
+          <a:blip xmlns:r="http://schemas.openxmlformats.org/officeDocument/2006/relationships" xmlns:a="http://schemas.openxmlformats.org/drawingml/2006/main" r:embed="Rd57f2eb6fd274cd7">
             <a:extLst>
               <a:ext uri="{96DAC541-7B7A-43D3-8B79-37D633B846F1}">
-                <asvg:svgBlip xmlns:asvg="http://schemas.microsoft.com/office/drawing/2016/SVG/main" r:embed="R0e15478984d44757"/>
+                <asvg:svgBlip xmlns:asvg="http://schemas.microsoft.com/office/drawing/2016/SVG/main" r:embed="R9a5e046f08444f9a"/>
               </a:ext>
             </a:extLst>
           </a:blip>
@@ -3597,7 +3597,7 @@
           <p:cNvPr id="2" name="title">
             <a:extLst xmlns:a="http://schemas.openxmlformats.org/drawingml/2006/main">
               <a:ext uri="{FF2B5EF4-FFF2-40B4-BE49-F238E27FC236}">
-                <a16:creationId xmlns:a16="http://schemas.microsoft.com/office/drawing/2014/main" id="{88BD99B1-7259-42E0-B4D9-F3FEA2107D56}"/>
+                <a16:creationId xmlns:a16="http://schemas.microsoft.com/office/drawing/2014/main" id="{C4EEBC76-0C5E-4B76-986A-667FEAC9A6AD}"/>
               </a:ext>
             </a:extLst>
           </p:cNvPr>
@@ -3647,7 +3647,7 @@
           <p:cNvPr id="3" name="metric-0">
             <a:extLst xmlns:a="http://schemas.openxmlformats.org/drawingml/2006/main">
               <a:ext uri="{FF2B5EF4-FFF2-40B4-BE49-F238E27FC236}">
-                <a16:creationId xmlns:a16="http://schemas.microsoft.com/office/drawing/2014/main" id="{45CB964E-5421-42EE-A174-09C4653AE245}"/>
+                <a16:creationId xmlns:a16="http://schemas.microsoft.com/office/drawing/2014/main" id="{84C50A50-4C00-4FF0-8BEB-CA398DECDED5}"/>
               </a:ext>
             </a:extLst>
           </p:cNvPr>
@@ -3697,7 +3697,7 @@
           <p:cNvPr id="4" name="metric-label-0">
             <a:extLst xmlns:a="http://schemas.openxmlformats.org/drawingml/2006/main">
               <a:ext uri="{FF2B5EF4-FFF2-40B4-BE49-F238E27FC236}">
-                <a16:creationId xmlns:a16="http://schemas.microsoft.com/office/drawing/2014/main" id="{AE0CE53E-8D9F-41D4-BB9B-5968D85989C7}"/>
+                <a16:creationId xmlns:a16="http://schemas.microsoft.com/office/drawing/2014/main" id="{3259C304-BA82-4277-8812-DDF36065F671}"/>
               </a:ext>
             </a:extLst>
           </p:cNvPr>
@@ -3747,7 +3747,7 @@
           <p:cNvPr id="5" name="metric-body-0">
             <a:extLst xmlns:a="http://schemas.openxmlformats.org/drawingml/2006/main">
               <a:ext uri="{FF2B5EF4-FFF2-40B4-BE49-F238E27FC236}">
-                <a16:creationId xmlns:a16="http://schemas.microsoft.com/office/drawing/2014/main" id="{B51218FA-5118-4F0C-A257-5D6395C30E0A}"/>
+                <a16:creationId xmlns:a16="http://schemas.microsoft.com/office/drawing/2014/main" id="{303F8387-6E1F-4C03-8AF8-4C420AF15C5C}"/>
               </a:ext>
             </a:extLst>
           </p:cNvPr>
@@ -3797,7 +3797,7 @@
           <p:cNvPr id="6" name="metric-divider-0">
             <a:extLst xmlns:a="http://schemas.openxmlformats.org/drawingml/2006/main">
               <a:ext uri="{FF2B5EF4-FFF2-40B4-BE49-F238E27FC236}">
-                <a16:creationId xmlns:a16="http://schemas.microsoft.com/office/drawing/2014/main" id="{933E8614-79CC-4124-89C0-F7B618F26CCB}"/>
+                <a16:creationId xmlns:a16="http://schemas.microsoft.com/office/drawing/2014/main" id="{24803F4F-461E-4C41-ACEE-BAB7A36DB229}"/>
               </a:ext>
             </a:extLst>
           </p:cNvPr>
@@ -3828,7 +3828,7 @@
           <p:cNvPr id="7" name="metric-1">
             <a:extLst xmlns:a="http://schemas.openxmlformats.org/drawingml/2006/main">
               <a:ext uri="{FF2B5EF4-FFF2-40B4-BE49-F238E27FC236}">
-                <a16:creationId xmlns:a16="http://schemas.microsoft.com/office/drawing/2014/main" id="{33D0A168-16EA-4889-A61F-3629C29C6C0B}"/>
+                <a16:creationId xmlns:a16="http://schemas.microsoft.com/office/drawing/2014/main" id="{2EDD7884-DA78-4ECC-B505-141630797D48}"/>
               </a:ext>
             </a:extLst>
           </p:cNvPr>
@@ -3878,7 +3878,7 @@
           <p:cNvPr id="8" name="metric-label-1">
             <a:extLst xmlns:a="http://schemas.openxmlformats.org/drawingml/2006/main">
               <a:ext uri="{FF2B5EF4-FFF2-40B4-BE49-F238E27FC236}">
-                <a16:creationId xmlns:a16="http://schemas.microsoft.com/office/drawing/2014/main" id="{77E059E5-F9AB-452A-A49A-0CE5A42C5D75}"/>
+                <a16:creationId xmlns:a16="http://schemas.microsoft.com/office/drawing/2014/main" id="{15479553-969A-4FB6-9F35-59E58DF885A2}"/>
               </a:ext>
             </a:extLst>
           </p:cNvPr>
@@ -3928,7 +3928,7 @@
           <p:cNvPr id="9" name="metric-body-1">
             <a:extLst xmlns:a="http://schemas.openxmlformats.org/drawingml/2006/main">
               <a:ext uri="{FF2B5EF4-FFF2-40B4-BE49-F238E27FC236}">
-                <a16:creationId xmlns:a16="http://schemas.microsoft.com/office/drawing/2014/main" id="{74418B7D-83AE-4B56-8C19-C341A38F681D}"/>
+                <a16:creationId xmlns:a16="http://schemas.microsoft.com/office/drawing/2014/main" id="{FEBDB1A1-7241-46C7-8D25-70C1B67CAA3E}"/>
               </a:ext>
             </a:extLst>
           </p:cNvPr>
@@ -3978,7 +3978,7 @@
           <p:cNvPr id="10" name="metric-divider-1">
             <a:extLst xmlns:a="http://schemas.openxmlformats.org/drawingml/2006/main">
               <a:ext uri="{FF2B5EF4-FFF2-40B4-BE49-F238E27FC236}">
-                <a16:creationId xmlns:a16="http://schemas.microsoft.com/office/drawing/2014/main" id="{B04B5D22-6CE5-4FD2-9C2F-7E75B9CB31E2}"/>
+                <a16:creationId xmlns:a16="http://schemas.microsoft.com/office/drawing/2014/main" id="{4DE0FAD1-0AC6-470E-AF79-F4B91BA56319}"/>
               </a:ext>
             </a:extLst>
           </p:cNvPr>
@@ -4009,7 +4009,7 @@
           <p:cNvPr id="11" name="metric-2">
             <a:extLst xmlns:a="http://schemas.openxmlformats.org/drawingml/2006/main">
               <a:ext uri="{FF2B5EF4-FFF2-40B4-BE49-F238E27FC236}">
-                <a16:creationId xmlns:a16="http://schemas.microsoft.com/office/drawing/2014/main" id="{3123B9D1-90D1-4EC5-8651-89861412BB6E}"/>
+                <a16:creationId xmlns:a16="http://schemas.microsoft.com/office/drawing/2014/main" id="{D48C0F54-1F62-4E28-A567-6565DA94F055}"/>
               </a:ext>
             </a:extLst>
           </p:cNvPr>
@@ -4059,7 +4059,7 @@
           <p:cNvPr id="12" name="metric-label-2">
             <a:extLst xmlns:a="http://schemas.openxmlformats.org/drawingml/2006/main">
               <a:ext uri="{FF2B5EF4-FFF2-40B4-BE49-F238E27FC236}">
-                <a16:creationId xmlns:a16="http://schemas.microsoft.com/office/drawing/2014/main" id="{C287C498-94CE-4C4E-A50D-E6E80BEF572B}"/>
+                <a16:creationId xmlns:a16="http://schemas.microsoft.com/office/drawing/2014/main" id="{419D05D2-381E-4BF9-94B9-211AA180307C}"/>
               </a:ext>
             </a:extLst>
           </p:cNvPr>
@@ -4109,7 +4109,7 @@
           <p:cNvPr id="13" name="metric-body-2">
             <a:extLst xmlns:a="http://schemas.openxmlformats.org/drawingml/2006/main">
               <a:ext uri="{FF2B5EF4-FFF2-40B4-BE49-F238E27FC236}">
-                <a16:creationId xmlns:a16="http://schemas.microsoft.com/office/drawing/2014/main" id="{7E92BA51-2117-4057-8C29-7D90655CE0D9}"/>
+                <a16:creationId xmlns:a16="http://schemas.microsoft.com/office/drawing/2014/main" id="{8B459B0E-3940-496C-AD16-EA18174435D8}"/>
               </a:ext>
             </a:extLst>
           </p:cNvPr>
@@ -4159,7 +4159,7 @@
           <p:cNvPr id="14" name="bottom-band">
             <a:extLst xmlns:a="http://schemas.openxmlformats.org/drawingml/2006/main">
               <a:ext uri="{FF2B5EF4-FFF2-40B4-BE49-F238E27FC236}">
-                <a16:creationId xmlns:a16="http://schemas.microsoft.com/office/drawing/2014/main" id="{1DC92F67-4475-4A0C-8A53-6370D7528864}"/>
+                <a16:creationId xmlns:a16="http://schemas.microsoft.com/office/drawing/2014/main" id="{BCCD9526-0B28-4430-81AD-170629684432}"/>
               </a:ext>
             </a:extLst>
           </p:cNvPr>
@@ -4190,7 +4190,7 @@
           <p:cNvPr id="15" name="bottom-copy">
             <a:extLst xmlns:a="http://schemas.openxmlformats.org/drawingml/2006/main">
               <a:ext uri="{FF2B5EF4-FFF2-40B4-BE49-F238E27FC236}">
-                <a16:creationId xmlns:a16="http://schemas.microsoft.com/office/drawing/2014/main" id="{46B10438-E4F5-48A9-88E3-4C9C87940D67}"/>
+                <a16:creationId xmlns:a16="http://schemas.microsoft.com/office/drawing/2014/main" id="{A8E0635F-9C49-4B62-BA93-32E4A79556F2}"/>
               </a:ext>
             </a:extLst>
           </p:cNvPr>
@@ -4238,7 +4238,7 @@
     </p:spTree>
     <p:extLst>
       <p:ext uri="{BB962C8B-B14F-4D97-AF65-F5344CB8AC3E}">
-        <p14:creationId xmlns:p14="http://schemas.microsoft.com/office/powerpoint/2010/main" val="481828226"/>
+        <p14:creationId xmlns:p14="http://schemas.microsoft.com/office/powerpoint/2010/main" val="1337339893"/>
       </p:ext>
     </p:extLst>
   </p:cSld>
@@ -4273,10 +4273,10 @@
           <p:nvPr/>
         </p:nvPicPr>
         <p:blipFill>
-          <a:blip xmlns:r="http://schemas.openxmlformats.org/officeDocument/2006/relationships" xmlns:a="http://schemas.openxmlformats.org/drawingml/2006/main" r:embed="R6d0436fc08ac4174">
+          <a:blip xmlns:r="http://schemas.openxmlformats.org/officeDocument/2006/relationships" xmlns:a="http://schemas.openxmlformats.org/drawingml/2006/main" r:embed="Rb22bf8eea4a54eb7">
             <a:extLst>
               <a:ext uri="{96DAC541-7B7A-43D3-8B79-37D633B846F1}">
-                <asvg:svgBlip xmlns:asvg="http://schemas.microsoft.com/office/drawing/2016/SVG/main" r:embed="R1559a60e65ef44fc"/>
+                <asvg:svgBlip xmlns:asvg="http://schemas.microsoft.com/office/drawing/2016/SVG/main" r:embed="Re8ee8192e67f4662"/>
               </a:ext>
             </a:extLst>
           </a:blip>
@@ -4297,7 +4297,7 @@
           <p:cNvPr id="2" name="title">
             <a:extLst xmlns:a="http://schemas.openxmlformats.org/drawingml/2006/main">
               <a:ext uri="{FF2B5EF4-FFF2-40B4-BE49-F238E27FC236}">
-                <a16:creationId xmlns:a16="http://schemas.microsoft.com/office/drawing/2014/main" id="{D2F3FB90-AB77-4C26-913A-4342A38C973C}"/>
+                <a16:creationId xmlns:a16="http://schemas.microsoft.com/office/drawing/2014/main" id="{27CFDFE3-305B-4A7E-A9F0-865ED24AE9B1}"/>
               </a:ext>
             </a:extLst>
           </p:cNvPr>
@@ -4347,7 +4347,7 @@
           <p:cNvPr id="3" name="subtitle">
             <a:extLst xmlns:a="http://schemas.openxmlformats.org/drawingml/2006/main">
               <a:ext uri="{FF2B5EF4-FFF2-40B4-BE49-F238E27FC236}">
-                <a16:creationId xmlns:a16="http://schemas.microsoft.com/office/drawing/2014/main" id="{DB7D3727-F287-4CCA-B354-64EB6AC8DD13}"/>
+                <a16:creationId xmlns:a16="http://schemas.microsoft.com/office/drawing/2014/main" id="{4100BE92-0A6E-48EE-9496-BAD5AF453C86}"/>
               </a:ext>
             </a:extLst>
           </p:cNvPr>
@@ -4397,7 +4397,7 @@
           <p:cNvPr id="4" name="rule-80-488">
             <a:extLst xmlns:a="http://schemas.openxmlformats.org/drawingml/2006/main">
               <a:ext uri="{FF2B5EF4-FFF2-40B4-BE49-F238E27FC236}">
-                <a16:creationId xmlns:a16="http://schemas.microsoft.com/office/drawing/2014/main" id="{50BC8649-194F-4088-A141-97D0BCA05BA2}"/>
+                <a16:creationId xmlns:a16="http://schemas.microsoft.com/office/drawing/2014/main" id="{4F858478-70CA-4248-9997-067A2D35DA28}"/>
               </a:ext>
             </a:extLst>
           </p:cNvPr>
@@ -4428,7 +4428,7 @@
           <p:cNvPr id="5" name="tagline">
             <a:extLst xmlns:a="http://schemas.openxmlformats.org/drawingml/2006/main">
               <a:ext uri="{FF2B5EF4-FFF2-40B4-BE49-F238E27FC236}">
-                <a16:creationId xmlns:a16="http://schemas.microsoft.com/office/drawing/2014/main" id="{9B3D442D-C092-4DF8-8AFA-75C2B17031B6}"/>
+                <a16:creationId xmlns:a16="http://schemas.microsoft.com/office/drawing/2014/main" id="{8D9FC9BE-B5AA-4314-A73D-524E42CC7EBC}"/>
               </a:ext>
             </a:extLst>
           </p:cNvPr>
@@ -4482,10 +4482,10 @@
           <p:nvPr/>
         </p:nvPicPr>
         <p:blipFill>
-          <a:blip xmlns:r="http://schemas.openxmlformats.org/officeDocument/2006/relationships" xmlns:a="http://schemas.openxmlformats.org/drawingml/2006/main" r:embed="R502297205c864cbc">
+          <a:blip xmlns:r="http://schemas.openxmlformats.org/officeDocument/2006/relationships" xmlns:a="http://schemas.openxmlformats.org/drawingml/2006/main" r:embed="Rcdf4c35179bf4810">
             <a:extLst>
               <a:ext uri="{96DAC541-7B7A-43D3-8B79-37D633B846F1}">
-                <asvg:svgBlip xmlns:asvg="http://schemas.microsoft.com/office/drawing/2016/SVG/main" r:embed="R7802ba2e741e469e"/>
+                <asvg:svgBlip xmlns:asvg="http://schemas.microsoft.com/office/drawing/2016/SVG/main" r:embed="R4da9d8e79a124891"/>
               </a:ext>
             </a:extLst>
           </a:blip>
@@ -4504,7 +4504,7 @@
     </p:spTree>
     <p:extLst>
       <p:ext uri="{BB962C8B-B14F-4D97-AF65-F5344CB8AC3E}">
-        <p14:creationId xmlns:p14="http://schemas.microsoft.com/office/powerpoint/2010/main" val="1377671147"/>
+        <p14:creationId xmlns:p14="http://schemas.microsoft.com/office/powerpoint/2010/main" val="1795531669"/>
       </p:ext>
     </p:extLst>
   </p:cSld>

</xml_diff>